<commit_message>
Update friend B deck with more comments on AI post
Co-Authored-By: Claude Sonnet 5.5 <noreply@anthropic.com>
Claude-Session: https://claude.ai/code/session_01YWYmCoF2kfC3GxD29xN2Db
</commit_message>
<xml_diff>
--- a/deliverables/邱偉浩-元智大學-10月B.pptx
+++ b/deliverables/邱偉浩-元智大學-10月B.pptx
@@ -4725,7 +4725,7 @@
                 <a:ea typeface="Calibri" pitchFamily="34" charset="-122"/>
                 <a:cs typeface="Calibri" pitchFamily="34" charset="-120"/>
               </a:rPr>
-              <a:t>案例 2 留言的看法(看得到的 12 則)</a:t>
+              <a:t>案例 2 留言的看法(看得到的 25 則)</a:t>
             </a:r>
             <a:endParaRPr lang="en-US" sz="1400" dirty="0"/>
           </a:p>
@@ -4739,8 +4739,8 @@
         </p:nvSpPr>
         <p:spPr>
           <a:xfrm>
-            <a:off x="457200" y="1508760"/>
-            <a:ext cx="2286000" cy="594360"/>
+            <a:off x="457200" y="1463040"/>
+            <a:ext cx="2514600" cy="457200"/>
           </a:xfrm>
           <a:prstGeom prst="rect">
             <a:avLst/>
@@ -4764,7 +4764,7 @@
                 <a:ea typeface="Calibri" pitchFamily="34" charset="-122"/>
                 <a:cs typeface="Calibri" pitchFamily="34" charset="-120"/>
               </a:rPr>
-              <a:t>每一代都一樣,沒有比較慘</a:t>
+              <a:t>每一代都一樣,又在喊苦</a:t>
             </a:r>
             <a:endParaRPr lang="en-US" sz="1300" dirty="0"/>
           </a:p>
@@ -4778,8 +4778,8 @@
         </p:nvSpPr>
         <p:spPr>
           <a:xfrm>
-            <a:off x="2788920" y="1600200"/>
-            <a:ext cx="2286000" cy="365760"/>
+            <a:off x="3017520" y="1527048"/>
+            <a:ext cx="2194560" cy="329184"/>
           </a:xfrm>
           <a:prstGeom prst="rect">
             <a:avLst/>
@@ -4803,8 +4803,8 @@
         </p:nvSpPr>
         <p:spPr>
           <a:xfrm>
-            <a:off x="5166360" y="1508760"/>
-            <a:ext cx="457200" cy="594360"/>
+            <a:off x="5303520" y="1463040"/>
+            <a:ext cx="457200" cy="457200"/>
           </a:xfrm>
           <a:prstGeom prst="rect">
             <a:avLst/>
@@ -4828,7 +4828,7 @@
                 <a:ea typeface="Calibri" pitchFamily="34" charset="-122"/>
                 <a:cs typeface="Calibri" pitchFamily="34" charset="-120"/>
               </a:rPr>
-              <a:t>5</a:t>
+              <a:t>8</a:t>
             </a:r>
             <a:endParaRPr lang="en-US" sz="1400" dirty="0"/>
           </a:p>
@@ -4842,8 +4842,8 @@
         </p:nvSpPr>
         <p:spPr>
           <a:xfrm>
-            <a:off x="457200" y="2240280"/>
-            <a:ext cx="2286000" cy="594360"/>
+            <a:off x="457200" y="1993392"/>
+            <a:ext cx="2514600" cy="457200"/>
           </a:xfrm>
           <a:prstGeom prst="rect">
             <a:avLst/>
@@ -4867,7 +4867,7 @@
                 <a:ea typeface="Calibri" pitchFamily="34" charset="-122"/>
                 <a:cs typeface="Calibri" pitchFamily="34" charset="-120"/>
               </a:rPr>
-              <a:t>AI 是工具,要學會用</a:t>
+              <a:t>AI 讓學習變方便,要學會用</a:t>
             </a:r>
             <a:endParaRPr lang="en-US" sz="1300" dirty="0"/>
           </a:p>
@@ -4881,8 +4881,8 @@
         </p:nvSpPr>
         <p:spPr>
           <a:xfrm>
-            <a:off x="2788920" y="2331720"/>
-            <a:ext cx="1371600" cy="365760"/>
+            <a:off x="3017520" y="2057400"/>
+            <a:ext cx="1920240" cy="329184"/>
           </a:xfrm>
           <a:prstGeom prst="rect">
             <a:avLst/>
@@ -4906,8 +4906,8 @@
         </p:nvSpPr>
         <p:spPr>
           <a:xfrm>
-            <a:off x="4251960" y="2240280"/>
-            <a:ext cx="457200" cy="594360"/>
+            <a:off x="5029200" y="1993392"/>
+            <a:ext cx="457200" cy="457200"/>
           </a:xfrm>
           <a:prstGeom prst="rect">
             <a:avLst/>
@@ -4931,7 +4931,7 @@
                 <a:ea typeface="Calibri" pitchFamily="34" charset="-122"/>
                 <a:cs typeface="Calibri" pitchFamily="34" charset="-120"/>
               </a:rPr>
-              <a:t>3</a:t>
+              <a:t>7</a:t>
             </a:r>
             <a:endParaRPr lang="en-US" sz="1400" dirty="0"/>
           </a:p>
@@ -4945,8 +4945,8 @@
         </p:nvSpPr>
         <p:spPr>
           <a:xfrm>
-            <a:off x="457200" y="2971800"/>
-            <a:ext cx="2286000" cy="594360"/>
+            <a:off x="457200" y="2523744"/>
+            <a:ext cx="2514600" cy="457200"/>
           </a:xfrm>
           <a:prstGeom prst="rect">
             <a:avLst/>
@@ -4970,7 +4970,7 @@
                 <a:ea typeface="Calibri" pitchFamily="34" charset="-122"/>
                 <a:cs typeface="Calibri" pitchFamily="34" charset="-120"/>
               </a:rPr>
-              <a:t>AI 取代不了的工作(產線、輪班)</a:t>
+              <a:t>要有自己的實力,不能只靠 AI</a:t>
             </a:r>
             <a:endParaRPr lang="en-US" sz="1300" dirty="0"/>
           </a:p>
@@ -4984,8 +4984,8 @@
         </p:nvSpPr>
         <p:spPr>
           <a:xfrm>
-            <a:off x="2788920" y="3063240"/>
-            <a:ext cx="1371600" cy="365760"/>
+            <a:off x="3017520" y="2587752"/>
+            <a:ext cx="1097280" cy="329184"/>
           </a:xfrm>
           <a:prstGeom prst="rect">
             <a:avLst/>
@@ -5009,8 +5009,8 @@
         </p:nvSpPr>
         <p:spPr>
           <a:xfrm>
-            <a:off x="4251960" y="2971800"/>
-            <a:ext cx="457200" cy="594360"/>
+            <a:off x="4206240" y="2523744"/>
+            <a:ext cx="457200" cy="457200"/>
           </a:xfrm>
           <a:prstGeom prst="rect">
             <a:avLst/>
@@ -5034,7 +5034,7 @@
                 <a:ea typeface="Calibri" pitchFamily="34" charset="-122"/>
                 <a:cs typeface="Calibri" pitchFamily="34" charset="-120"/>
               </a:rPr>
-              <a:t>3</a:t>
+              <a:t>4</a:t>
             </a:r>
             <a:endParaRPr lang="en-US" sz="1400" dirty="0"/>
           </a:p>
@@ -5048,8 +5048,8 @@
         </p:nvSpPr>
         <p:spPr>
           <a:xfrm>
-            <a:off x="457200" y="3703320"/>
-            <a:ext cx="2286000" cy="594360"/>
+            <a:off x="457200" y="3054096"/>
+            <a:ext cx="2514600" cy="457200"/>
           </a:xfrm>
           <a:prstGeom prst="rect">
             <a:avLst/>
@@ -5073,7 +5073,7 @@
                 <a:ea typeface="Calibri" pitchFamily="34" charset="-122"/>
                 <a:cs typeface="Calibri" pitchFamily="34" charset="-120"/>
               </a:rPr>
-              <a:t>大學價值變低</a:t>
+              <a:t>AI 取代不了的工作(產線、輪班)</a:t>
             </a:r>
             <a:endParaRPr lang="en-US" sz="1300" dirty="0"/>
           </a:p>
@@ -5087,8 +5087,8 @@
         </p:nvSpPr>
         <p:spPr>
           <a:xfrm>
-            <a:off x="2788920" y="3794760"/>
-            <a:ext cx="457200" cy="365760"/>
+            <a:off x="3017520" y="3118104"/>
+            <a:ext cx="822960" cy="329184"/>
           </a:xfrm>
           <a:prstGeom prst="rect">
             <a:avLst/>
@@ -5112,8 +5112,8 @@
         </p:nvSpPr>
         <p:spPr>
           <a:xfrm>
-            <a:off x="3337560" y="3703320"/>
-            <a:ext cx="457200" cy="594360"/>
+            <a:off x="3931920" y="3054096"/>
+            <a:ext cx="457200" cy="457200"/>
           </a:xfrm>
           <a:prstGeom prst="rect">
             <a:avLst/>
@@ -5137,6 +5137,212 @@
                 <a:ea typeface="Calibri" pitchFamily="34" charset="-122"/>
                 <a:cs typeface="Calibri" pitchFamily="34" charset="-120"/>
               </a:rPr>
+              <a:t>3</a:t>
+            </a:r>
+            <a:endParaRPr lang="en-US" sz="1400" dirty="0"/>
+          </a:p>
+        </p:txBody>
+      </p:sp>
+      <p:sp>
+        <p:nvSpPr>
+          <p:cNvPr id="18" name="Text 16"/>
+          <p:cNvSpPr txBox="1"/>
+          <p:nvPr/>
+        </p:nvSpPr>
+        <p:spPr>
+          <a:xfrm>
+            <a:off x="457200" y="3584448"/>
+            <a:ext cx="2514600" cy="457200"/>
+          </a:xfrm>
+          <a:prstGeom prst="rect">
+            <a:avLst/>
+          </a:prstGeom>
+          <a:noFill/>
+          <a:ln/>
+        </p:spPr>
+        <p:txBody>
+          <a:bodyPr wrap="square" lIns="0" tIns="0" rIns="0" bIns="0" rtlCol="0" anchor="ctr"/>
+          <a:lstStyle/>
+          <a:p>
+            <a:pPr indent="0" marL="0">
+              <a:buNone/>
+            </a:pPr>
+            <a:r>
+              <a:rPr lang="en-US" sz="1300" dirty="0">
+                <a:solidFill>
+                  <a:srgbClr val="222222"/>
+                </a:solidFill>
+                <a:latin typeface="Calibri" pitchFamily="34" charset="0"/>
+                <a:ea typeface="Calibri" pitchFamily="34" charset="-122"/>
+                <a:cs typeface="Calibri" pitchFamily="34" charset="-120"/>
+              </a:rPr>
+              <a:t>擔心 AI 衝擊所有人</a:t>
+            </a:r>
+            <a:endParaRPr lang="en-US" sz="1300" dirty="0"/>
+          </a:p>
+        </p:txBody>
+      </p:sp>
+      <p:sp>
+        <p:nvSpPr>
+          <p:cNvPr id="19" name="Shape 17"/>
+          <p:cNvSpPr/>
+          <p:nvPr/>
+        </p:nvSpPr>
+        <p:spPr>
+          <a:xfrm>
+            <a:off x="3017520" y="3648456"/>
+            <a:ext cx="548640" cy="329184"/>
+          </a:xfrm>
+          <a:prstGeom prst="rect">
+            <a:avLst/>
+          </a:prstGeom>
+          <a:solidFill>
+            <a:srgbClr val="1B2A41"/>
+          </a:solidFill>
+          <a:ln w="12700">
+            <a:solidFill>
+              <a:srgbClr val="1B2A41"/>
+            </a:solidFill>
+            <a:prstDash val="solid"/>
+          </a:ln>
+        </p:spPr>
+      </p:sp>
+      <p:sp>
+        <p:nvSpPr>
+          <p:cNvPr id="20" name="Text 18"/>
+          <p:cNvSpPr txBox="1"/>
+          <p:nvPr/>
+        </p:nvSpPr>
+        <p:spPr>
+          <a:xfrm>
+            <a:off x="3657600" y="3584448"/>
+            <a:ext cx="457200" cy="457200"/>
+          </a:xfrm>
+          <a:prstGeom prst="rect">
+            <a:avLst/>
+          </a:prstGeom>
+          <a:noFill/>
+          <a:ln/>
+        </p:spPr>
+        <p:txBody>
+          <a:bodyPr wrap="square" lIns="0" tIns="0" rIns="0" bIns="0" rtlCol="0" anchor="ctr"/>
+          <a:lstStyle/>
+          <a:p>
+            <a:pPr indent="0" marL="0">
+              <a:buNone/>
+            </a:pPr>
+            <a:r>
+              <a:rPr lang="en-US" sz="1400" b="1" dirty="0">
+                <a:solidFill>
+                  <a:srgbClr val="1B2A41"/>
+                </a:solidFill>
+                <a:latin typeface="Calibri" pitchFamily="34" charset="0"/>
+                <a:ea typeface="Calibri" pitchFamily="34" charset="-122"/>
+                <a:cs typeface="Calibri" pitchFamily="34" charset="-120"/>
+              </a:rPr>
+              <a:t>2</a:t>
+            </a:r>
+            <a:endParaRPr lang="en-US" sz="1400" dirty="0"/>
+          </a:p>
+        </p:txBody>
+      </p:sp>
+      <p:sp>
+        <p:nvSpPr>
+          <p:cNvPr id="21" name="Text 19"/>
+          <p:cNvSpPr txBox="1"/>
+          <p:nvPr/>
+        </p:nvSpPr>
+        <p:spPr>
+          <a:xfrm>
+            <a:off x="457200" y="4114800"/>
+            <a:ext cx="2514600" cy="457200"/>
+          </a:xfrm>
+          <a:prstGeom prst="rect">
+            <a:avLst/>
+          </a:prstGeom>
+          <a:noFill/>
+          <a:ln/>
+        </p:spPr>
+        <p:txBody>
+          <a:bodyPr wrap="square" lIns="0" tIns="0" rIns="0" bIns="0" rtlCol="0" anchor="ctr"/>
+          <a:lstStyle/>
+          <a:p>
+            <a:pPr indent="0" marL="0">
+              <a:buNone/>
+            </a:pPr>
+            <a:r>
+              <a:rPr lang="en-US" sz="1300" dirty="0">
+                <a:solidFill>
+                  <a:srgbClr val="222222"/>
+                </a:solidFill>
+                <a:latin typeface="Calibri" pitchFamily="34" charset="0"/>
+                <a:ea typeface="Calibri" pitchFamily="34" charset="-122"/>
+                <a:cs typeface="Calibri" pitchFamily="34" charset="-120"/>
+              </a:rPr>
+              <a:t>大學價值變低</a:t>
+            </a:r>
+            <a:endParaRPr lang="en-US" sz="1300" dirty="0"/>
+          </a:p>
+        </p:txBody>
+      </p:sp>
+      <p:sp>
+        <p:nvSpPr>
+          <p:cNvPr id="22" name="Shape 20"/>
+          <p:cNvSpPr/>
+          <p:nvPr/>
+        </p:nvSpPr>
+        <p:spPr>
+          <a:xfrm>
+            <a:off x="3017520" y="4178808"/>
+            <a:ext cx="274320" cy="329184"/>
+          </a:xfrm>
+          <a:prstGeom prst="rect">
+            <a:avLst/>
+          </a:prstGeom>
+          <a:solidFill>
+            <a:srgbClr val="1B2A41"/>
+          </a:solidFill>
+          <a:ln w="12700">
+            <a:solidFill>
+              <a:srgbClr val="1B2A41"/>
+            </a:solidFill>
+            <a:prstDash val="solid"/>
+          </a:ln>
+        </p:spPr>
+      </p:sp>
+      <p:sp>
+        <p:nvSpPr>
+          <p:cNvPr id="23" name="Text 21"/>
+          <p:cNvSpPr txBox="1"/>
+          <p:nvPr/>
+        </p:nvSpPr>
+        <p:spPr>
+          <a:xfrm>
+            <a:off x="3383280" y="4114800"/>
+            <a:ext cx="457200" cy="457200"/>
+          </a:xfrm>
+          <a:prstGeom prst="rect">
+            <a:avLst/>
+          </a:prstGeom>
+          <a:noFill/>
+          <a:ln/>
+        </p:spPr>
+        <p:txBody>
+          <a:bodyPr wrap="square" lIns="0" tIns="0" rIns="0" bIns="0" rtlCol="0" anchor="ctr"/>
+          <a:lstStyle/>
+          <a:p>
+            <a:pPr indent="0" marL="0">
+              <a:buNone/>
+            </a:pPr>
+            <a:r>
+              <a:rPr lang="en-US" sz="1400" b="1" dirty="0">
+                <a:solidFill>
+                  <a:srgbClr val="1B2A41"/>
+                </a:solidFill>
+                <a:latin typeface="Calibri" pitchFamily="34" charset="0"/>
+                <a:ea typeface="Calibri" pitchFamily="34" charset="-122"/>
+                <a:cs typeface="Calibri" pitchFamily="34" charset="-120"/>
+              </a:rPr>
               <a:t>1</a:t>
             </a:r>
             <a:endParaRPr lang="en-US" sz="1400" dirty="0"/>
@@ -5145,7 +5351,7 @@
       </p:sp>
       <p:sp>
         <p:nvSpPr>
-          <p:cNvPr id="18" name="Shape 16"/>
+          <p:cNvPr id="24" name="Shape 22"/>
           <p:cNvSpPr/>
           <p:nvPr/>
         </p:nvSpPr>
@@ -5172,7 +5378,7 @@
       </p:sp>
       <p:sp>
         <p:nvSpPr>
-          <p:cNvPr id="19" name="Text 17"/>
+          <p:cNvPr id="25" name="Text 23"/>
           <p:cNvSpPr txBox="1"/>
           <p:nvPr/>
         </p:nvSpPr>
@@ -5211,7 +5417,7 @@
       </p:sp>
       <p:sp>
         <p:nvSpPr>
-          <p:cNvPr id="20" name="Text 18"/>
+          <p:cNvPr id="26" name="Text 24"/>
           <p:cNvSpPr txBox="1"/>
           <p:nvPr/>
         </p:nvSpPr>
@@ -5285,6 +5491,26 @@
                 <a:ea typeface="Calibri" pitchFamily="34" charset="-122"/>
                 <a:cs typeface="Calibri" pitchFamily="34" charset="-120"/>
               </a:rPr>
+              <a:t>「每一代都有混得好的,混得差的」(8 讚)</a:t>
+            </a:r>
+            <a:endParaRPr lang="en-US" sz="1300" dirty="0"/>
+          </a:p>
+          <a:p>
+            <a:pPr indent="0" marL="0">
+              <a:spcAft>
+                <a:spcPts val="400"/>
+              </a:spcAft>
+              <a:buNone/>
+            </a:pPr>
+            <a:r>
+              <a:rPr lang="en-US" sz="1300" dirty="0">
+                <a:solidFill>
+                  <a:srgbClr val="222222"/>
+                </a:solidFill>
+                <a:latin typeface="Calibri" pitchFamily="34" charset="0"/>
+                <a:ea typeface="Calibri" pitchFamily="34" charset="-122"/>
+                <a:cs typeface="Calibri" pitchFamily="34" charset="-120"/>
+              </a:rPr>
               <a:t>「可以畢業到產線或設備商輪班,AI 和機器人都無法取代」(14 讚)</a:t>
             </a:r>
             <a:endParaRPr lang="en-US" sz="1300" dirty="0"/>
@@ -5293,14 +5519,14 @@
       </p:sp>
       <p:sp>
         <p:nvSpPr>
-          <p:cNvPr id="21" name="Text 19"/>
-          <p:cNvSpPr txBox="1"/>
-          <p:nvPr/>
-        </p:nvSpPr>
-        <p:spPr>
-          <a:xfrm>
-            <a:off x="457200" y="4526280"/>
-            <a:ext cx="5120640" cy="457200"/>
+          <p:cNvPr id="27" name="Text 25"/>
+          <p:cNvSpPr txBox="1"/>
+          <p:nvPr/>
+        </p:nvSpPr>
+        <p:spPr>
+          <a:xfrm>
+            <a:off x="457200" y="4663440"/>
+            <a:ext cx="5120640" cy="365760"/>
           </a:xfrm>
           <a:prstGeom prst="rect">
             <a:avLst/>
@@ -5324,7 +5550,7 @@
                 <a:ea typeface="Calibri" pitchFamily="34" charset="-122"/>
                 <a:cs typeface="Calibri" pitchFamily="34" charset="-120"/>
               </a:rPr>
-              <a:t>一則留言只算一種看法;這是看得到的 12 則,不是全部 188 則。</a:t>
+              <a:t>一則留言只算一種看法;這是看得到的 25 則,不是全部 188 則。</a:t>
             </a:r>
             <a:endParaRPr lang="en-US" sz="1100" dirty="0"/>
           </a:p>
@@ -6165,7 +6391,7 @@
                 <a:ea typeface="Calibri" pitchFamily="34" charset="-122"/>
                 <a:cs typeface="Calibri" pitchFamily="34" charset="-120"/>
               </a:rPr>
-              <a:t>談 AI,最多人覺得「每一代都有難處」,也有人說要學會用 AI</a:t>
+              <a:t>談 AI,有人覺得每一代都有難處(8 則),也有人覺得 AI 讓學習變方便(7 則)</a:t>
             </a:r>
             <a:endParaRPr lang="en-US" sz="1300" dirty="0"/>
           </a:p>

</xml_diff>

<commit_message>
Update friend B deck: 30 comments tallied on AI post
Co-Authored-By: Claude Sonnet 5.5 <noreply@anthropic.com>
Claude-Session: https://claude.ai/code/session_01YWYmCoF2kfC3GxD29xN2Db
</commit_message>
<xml_diff>
--- a/deliverables/邱偉浩-元智大學-10月B.pptx
+++ b/deliverables/邱偉浩-元智大學-10月B.pptx
@@ -4725,7 +4725,7 @@
                 <a:ea typeface="Calibri" pitchFamily="34" charset="-122"/>
                 <a:cs typeface="Calibri" pitchFamily="34" charset="-120"/>
               </a:rPr>
-              <a:t>案例 2 留言的看法(看得到的 25 則)</a:t>
+              <a:t>案例 2 留言的看法(看得到的 30 則)</a:t>
             </a:r>
             <a:endParaRPr lang="en-US" sz="1400" dirty="0"/>
           </a:p>
@@ -4828,7 +4828,7 @@
                 <a:ea typeface="Calibri" pitchFamily="34" charset="-122"/>
                 <a:cs typeface="Calibri" pitchFamily="34" charset="-120"/>
               </a:rPr>
-              <a:t>8</a:t>
+              <a:t>12</a:t>
             </a:r>
             <a:endParaRPr lang="en-US" sz="1400" dirty="0"/>
           </a:p>
@@ -4882,7 +4882,7 @@
         <p:spPr>
           <a:xfrm>
             <a:off x="3017520" y="2057400"/>
-            <a:ext cx="1920240" cy="329184"/>
+            <a:ext cx="1280160" cy="329184"/>
           </a:xfrm>
           <a:prstGeom prst="rect">
             <a:avLst/>
@@ -4906,7 +4906,7 @@
         </p:nvSpPr>
         <p:spPr>
           <a:xfrm>
-            <a:off x="5029200" y="1993392"/>
+            <a:off x="4389120" y="1993392"/>
             <a:ext cx="457200" cy="457200"/>
           </a:xfrm>
           <a:prstGeom prst="rect">
@@ -4985,7 +4985,7 @@
         <p:spPr>
           <a:xfrm>
             <a:off x="3017520" y="2587752"/>
-            <a:ext cx="1097280" cy="329184"/>
+            <a:ext cx="914400" cy="329184"/>
           </a:xfrm>
           <a:prstGeom prst="rect">
             <a:avLst/>
@@ -5009,7 +5009,7 @@
         </p:nvSpPr>
         <p:spPr>
           <a:xfrm>
-            <a:off x="4206240" y="2523744"/>
+            <a:off x="4023360" y="2523744"/>
             <a:ext cx="457200" cy="457200"/>
           </a:xfrm>
           <a:prstGeom prst="rect">
@@ -5034,7 +5034,7 @@
                 <a:ea typeface="Calibri" pitchFamily="34" charset="-122"/>
                 <a:cs typeface="Calibri" pitchFamily="34" charset="-120"/>
               </a:rPr>
-              <a:t>4</a:t>
+              <a:t>5</a:t>
             </a:r>
             <a:endParaRPr lang="en-US" sz="1400" dirty="0"/>
           </a:p>
@@ -5088,7 +5088,7 @@
         <p:spPr>
           <a:xfrm>
             <a:off x="3017520" y="3118104"/>
-            <a:ext cx="822960" cy="329184"/>
+            <a:ext cx="548640" cy="329184"/>
           </a:xfrm>
           <a:prstGeom prst="rect">
             <a:avLst/>
@@ -5112,7 +5112,7 @@
         </p:nvSpPr>
         <p:spPr>
           <a:xfrm>
-            <a:off x="3931920" y="3054096"/>
+            <a:off x="3657600" y="3054096"/>
             <a:ext cx="457200" cy="457200"/>
           </a:xfrm>
           <a:prstGeom prst="rect">
@@ -5191,7 +5191,7 @@
         <p:spPr>
           <a:xfrm>
             <a:off x="3017520" y="3648456"/>
-            <a:ext cx="548640" cy="329184"/>
+            <a:ext cx="365760" cy="329184"/>
           </a:xfrm>
           <a:prstGeom prst="rect">
             <a:avLst/>
@@ -5215,7 +5215,7 @@
         </p:nvSpPr>
         <p:spPr>
           <a:xfrm>
-            <a:off x="3657600" y="3584448"/>
+            <a:off x="3474720" y="3584448"/>
             <a:ext cx="457200" cy="457200"/>
           </a:xfrm>
           <a:prstGeom prst="rect">
@@ -5294,7 +5294,7 @@
         <p:spPr>
           <a:xfrm>
             <a:off x="3017520" y="4178808"/>
-            <a:ext cx="274320" cy="329184"/>
+            <a:ext cx="182880" cy="329184"/>
           </a:xfrm>
           <a:prstGeom prst="rect">
             <a:avLst/>
@@ -5318,7 +5318,7 @@
         </p:nvSpPr>
         <p:spPr>
           <a:xfrm>
-            <a:off x="3383280" y="4114800"/>
+            <a:off x="3291840" y="4114800"/>
             <a:ext cx="457200" cy="457200"/>
           </a:xfrm>
           <a:prstGeom prst="rect">
@@ -5550,7 +5550,7 @@
                 <a:ea typeface="Calibri" pitchFamily="34" charset="-122"/>
                 <a:cs typeface="Calibri" pitchFamily="34" charset="-120"/>
               </a:rPr>
-              <a:t>一則留言只算一種看法;這是看得到的 25 則,不是全部 188 則。</a:t>
+              <a:t>一則留言只算一種看法;這是看得到的 30 則(回覆別人的 3 則沒算),不是全部 188 則。</a:t>
             </a:r>
             <a:endParaRPr lang="en-US" sz="1100" dirty="0"/>
           </a:p>
@@ -6391,7 +6391,7 @@
                 <a:ea typeface="Calibri" pitchFamily="34" charset="-122"/>
                 <a:cs typeface="Calibri" pitchFamily="34" charset="-120"/>
               </a:rPr>
-              <a:t>談 AI,有人覺得每一代都有難處(8 則),也有人覺得 AI 讓學習變方便(7 則)</a:t>
+              <a:t>談 AI,有人覺得每一代都有難處(12 則),也有人覺得 AI 讓學習變方便(7 則)</a:t>
             </a:r>
             <a:endParaRPr lang="en-US" sz="1300" dirty="0"/>
           </a:p>

</xml_diff>